<commit_message>
Fix Slide 2 truncation cut-off bug and regenerate executive presentation
- Added word-boundary truncation helper with ellipsis to presentation_generator.py
- Replaced raw character slices with clean word-boundary truncation
- Re-generated Portfolio_Health_Report_202607.pptx with the fixes applied
</commit_message>
<xml_diff>
--- a/presentations/Portfolio_Health_Report_202607.pptx
+++ b/presentations/Portfolio_Health_Report_202607.pptx
@@ -3242,7 +3242,7 @@
                   <a:srgbClr val="8E99AB"/>
                 </a:solidFill>
               </a:rPr>
-              <a:t>Critical Delays and Widespread Issues Demand Immediate Intervention Across Key Zycus S2P Implementations.</a:t>
+              <a:t>Portfolio at Critical Red: Significant Delays and Execution Shortfalls Jeopardize Key S2P Implementations.</a:t>
             </a:r>
           </a:p>
         </p:txBody>
@@ -3567,7 +3567,7 @@
                   <a:srgbClr val="8E99AB"/>
                 </a:solidFill>
               </a:rPr>
-              <a:t>Both Zycus S2P projects, UniSan and Titan, are currently rated Red for July 2026. The portfolio is grappling with significant schedule slippage on critical milestones, a large volume of tasks flagged for urgent attention (over 100 Red/Yellow tasks combined), and underlying issues in task completion and dependency resolution. Without immediate and aggressive intervention, planned project timelines are at high risk.</a:t>
+              <a:t>The Zycus S2P portfolio is in a critical Red state, with both Titan and UniSan implementations facing severe challenges. Titan is significantly behind schedule with core 'Build' (51 days overdue) and 'Migration' (27 days overdue), hindering overall progress. UniSan, despite being technically ahead of schedule by 2 days, lags substantially with only 38.8% task completion against an expected 61.7% and has 42 critical 'Red' tasks outstanding.</a:t>
             </a:r>
           </a:p>
         </p:txBody>
@@ -3721,7 +3721,7 @@
                   <a:srgbClr val="FFFFFF"/>
                 </a:solidFill>
               </a:rPr>
-              <a:t>Zycus - UniSan S2P Implementation</a:t>
+              <a:t>Zycus - Titan S2P Implementation</a:t>
             </a:r>
           </a:p>
         </p:txBody>
@@ -3755,7 +3755,7 @@
                   <a:srgbClr val="8E99AB"/>
                 </a:solidFill>
               </a:rPr>
-              <a:t>The project is critically Red due to a significant 22.9% completion deficit against target and 42 cr</a:t>
+              <a:t>Critical Red state primarily due to 51-day delay on 'Build' and 27-day delay on 'Migration' milestones, compounded by...</a:t>
             </a:r>
           </a:p>
         </p:txBody>
@@ -3789,7 +3789,7 @@
                   <a:srgbClr val="008BFF"/>
                 </a:solidFill>
               </a:rPr>
-              <a:t>▶ Initiate an immediate deep dive on the 42 Red tasks and the 175 'Not Started' ta</a:t>
+              <a:t>&gt;&gt; Immediate re-baselining of the project plan, direct PM intervention to resolve critical...</a:t>
             </a:r>
           </a:p>
         </p:txBody>
@@ -3943,7 +3943,7 @@
                   <a:srgbClr val="FFFFFF"/>
                 </a:solidFill>
               </a:rPr>
-              <a:t>Zycus - Titan S2P Implementation</a:t>
+              <a:t>Zycus - UniSan S2P Implementation</a:t>
             </a:r>
           </a:p>
         </p:txBody>
@@ -3977,7 +3977,7 @@
                   <a:srgbClr val="8E99AB"/>
                 </a:solidFill>
               </a:rPr>
-              <a:t>This project is in a critical Red state due to significant delays on 'Build' (51 days overdue) and '</a:t>
+              <a:t>Red status due to a substantial 22.9% deficit in task completion against plan, despite being reported as slightly ahead...</a:t>
             </a:r>
           </a:p>
         </p:txBody>
@@ -4011,7 +4011,7 @@
                   <a:srgbClr val="008BFF"/>
                 </a:solidFill>
               </a:rPr>
-              <a:t>▶ Urgently review and re-baseline the project plan for logical consistency, expedi</a:t>
+              <a:t>&gt;&gt; Deep dive into 175 'Not Started' and 42 'Red' tasks to identify root causes and blockers,...</a:t>
             </a:r>
           </a:p>
         </p:txBody>
@@ -4268,7 +4268,7 @@
                   <a:srgbClr val="FFFFFF"/>
                 </a:solidFill>
               </a:rPr>
-              <a:t>**Widespread Schedule Risk &amp; Completion Deficits**: Both projects exhibit critical schedule concerns and completion rate issues. UniSan shows a 22.9% completion deficit with 42 tasks flagged Red, while Titan has critical milestones overdue by 51 and 27 days respectively, alongside a 4.3% completion shortfall.</a:t>
+              <a:t>Both S2P implementation projects are currently rated Red, signaling widespread project health concerns across the portfolio.</a:t>
             </a:r>
           </a:p>
         </p:txBody>
@@ -4379,7 +4379,7 @@
                   <a:srgbClr val="FFFFFF"/>
                 </a:solidFill>
               </a:rPr>
-              <a:t>**Blocker Resolution Bottlenecks**: A high volume of tasks are flagged as Red/Yellow across both projects (UniSan: 42 Red, 9 Yellow; Titan: 60 Red, 146 Yellow), and specific critical dependencies (e.g., JDE mapping, OTK data in Titan) remain unresolved, indicating systemic challenges in timely issue escalation and resolution.</a:t>
+              <a:t>Significant completion rate deficits and critical milestone delays are a recurring theme; Titan faces 51-day delays on 'Build', while UniSan shows a substantial 22.9% shortfall in task completion.</a:t>
             </a:r>
           </a:p>
         </p:txBody>
@@ -4490,7 +4490,7 @@
                   <a:srgbClr val="FFFFFF"/>
                 </a:solidFill>
               </a:rPr>
-              <a:t>**Project Plan Integrity Concerns**: Inconsistent milestone reporting in the Titan project (Go Live complete while preceding Migration and subsequent Hypercare are still ongoing/overdue) highlights a fundamental issue with project plan accuracy and tracking methodology, impacting reliable forecasting and trust.</a:t>
+              <a:t>Issues with project plan integrity, dependency management, and Project Management engagement are evident, leading to critical path delays and potential decision-making bottlenecks.</a:t>
             </a:r>
           </a:p>
         </p:txBody>
@@ -4498,117 +4498,6 @@
       <p:sp>
         <p:nvSpPr>
           <p:cNvPr id="13" name="Rectangle 12"/>
-          <p:cNvSpPr/>
-          <p:nvPr/>
-        </p:nvSpPr>
-        <p:spPr>
-          <a:xfrm>
-            <a:off x="365760" y="3931920"/>
-            <a:ext cx="502920" cy="502920"/>
-          </a:xfrm>
-          <a:prstGeom prst="rect">
-            <a:avLst/>
-          </a:prstGeom>
-          <a:solidFill>
-            <a:srgbClr val="008BFF"/>
-          </a:solidFill>
-          <a:ln>
-            <a:noFill/>
-          </a:ln>
-        </p:spPr>
-        <p:style>
-          <a:lnRef idx="1">
-            <a:schemeClr val="accent1"/>
-          </a:lnRef>
-          <a:fillRef idx="3">
-            <a:schemeClr val="accent1"/>
-          </a:fillRef>
-          <a:effectRef idx="2">
-            <a:schemeClr val="accent1"/>
-          </a:effectRef>
-          <a:fontRef idx="minor">
-            <a:schemeClr val="lt1"/>
-          </a:fontRef>
-        </p:style>
-        <p:txBody>
-          <a:bodyPr rtlCol="0" anchor="ctr"/>
-          <a:lstStyle/>
-          <a:p>
-            <a:pPr algn="ctr"/>
-          </a:p>
-        </p:txBody>
-      </p:sp>
-      <p:sp>
-        <p:nvSpPr>
-          <p:cNvPr id="14" name="TextBox 13"/>
-          <p:cNvSpPr txBox="1"/>
-          <p:nvPr/>
-        </p:nvSpPr>
-        <p:spPr>
-          <a:xfrm>
-            <a:off x="365760" y="3986784"/>
-            <a:ext cx="502920" cy="402336"/>
-          </a:xfrm>
-          <a:prstGeom prst="rect">
-            <a:avLst/>
-          </a:prstGeom>
-          <a:noFill/>
-        </p:spPr>
-        <p:txBody>
-          <a:bodyPr wrap="square">
-            <a:spAutoFit/>
-          </a:bodyPr>
-          <a:lstStyle/>
-          <a:p>
-            <a:pPr algn="ctr"/>
-            <a:r>
-              <a:rPr sz="1400" b="1" i="0">
-                <a:solidFill>
-                  <a:srgbClr val="FFFFFF"/>
-                </a:solidFill>
-              </a:rPr>
-              <a:t>4</a:t>
-            </a:r>
-          </a:p>
-        </p:txBody>
-      </p:sp>
-      <p:sp>
-        <p:nvSpPr>
-          <p:cNvPr id="15" name="TextBox 14"/>
-          <p:cNvSpPr txBox="1"/>
-          <p:nvPr/>
-        </p:nvSpPr>
-        <p:spPr>
-          <a:xfrm>
-            <a:off x="1005840" y="3931920"/>
-            <a:ext cx="10515600" cy="822960"/>
-          </a:xfrm>
-          <a:prstGeom prst="rect">
-            <a:avLst/>
-          </a:prstGeom>
-          <a:noFill/>
-        </p:spPr>
-        <p:txBody>
-          <a:bodyPr wrap="square">
-            <a:spAutoFit/>
-          </a:bodyPr>
-          <a:lstStyle/>
-          <a:p>
-            <a:pPr algn="l"/>
-            <a:r>
-              <a:rPr sz="1300" b="0" i="0">
-                <a:solidFill>
-                  <a:srgbClr val="FFFFFF"/>
-                </a:solidFill>
-              </a:rPr>
-              <a:t>**Potential Resource/Engagement Gaps**: UniSan has 175 'Not Started' tasks, and Titan shows repeated direct requests to the Project Manager for critical meetings, suggesting potential resource allocation or PM engagement bottlenecks impacting critical path progress.</a:t>
-            </a:r>
-          </a:p>
-        </p:txBody>
-      </p:sp>
-      <p:sp>
-        <p:nvSpPr>
-          <p:cNvPr id="16" name="Rectangle 15"/>
           <p:cNvSpPr/>
           <p:nvPr/>
         </p:nvSpPr>
@@ -4858,7 +4747,7 @@
                   <a:srgbClr val="FFFFFF"/>
                 </a:solidFill>
               </a:rPr>
-              <a:t>Project Plan Data Inaccuracy</a:t>
+              <a:t>Widespread Schedule &amp; Completion Slippage</a:t>
             </a:r>
           </a:p>
         </p:txBody>
@@ -4892,7 +4781,7 @@
                   <a:srgbClr val="8E99AB"/>
                 </a:solidFill>
               </a:rPr>
-              <a:t>The Titan project's inconsistent milestone reporting suggests fundamental flaws in plan logic and tracking, making current status assessment and future forecasting unreliable for the entire portfolio.</a:t>
+              <a:t>Both projects face critical delays on key milestones or significant deficits in task completion, threatening overall timelines and Go Live commitments.</a:t>
             </a:r>
           </a:p>
         </p:txBody>
@@ -5003,7 +4892,7 @@
                   <a:srgbClr val="FFFFFF"/>
                 </a:solidFill>
               </a:rPr>
-              <a:t>Persistent &amp; Deep Schedule Slippage</a:t>
+              <a:t>Project Management &amp; Leadership Bottlenecks</a:t>
             </a:r>
           </a:p>
         </p:txBody>
@@ -5037,7 +4926,7 @@
                   <a:srgbClr val="8E99AB"/>
                 </a:solidFill>
               </a:rPr>
-              <a:t>Both projects face significant delays (Titan's Build 51 days overdue; UniSan's 42 Red tasks, despite an overall 'ahead' schedule) which will inevitably push back go-live dates if unaddressed.</a:t>
+              <a:t>Direct requests for PM engagement and a high number of unaddressed 'Red' tasks suggest potential leadership and facilitation gaps impacting progress.</a:t>
             </a:r>
           </a:p>
         </p:txBody>
@@ -5148,7 +5037,7 @@
                   <a:srgbClr val="FFFFFF"/>
                 </a:solidFill>
               </a:rPr>
-              <a:t>Blocker &amp; Dependency Gridlock</a:t>
+              <a:t>Underlying Project Plan &amp; Tracking Flaws</a:t>
             </a:r>
           </a:p>
         </p:txBody>
@@ -5182,7 +5071,7 @@
                   <a:srgbClr val="8E99AB"/>
                 </a:solidFill>
               </a:rPr>
-              <a:t>Outstanding critical dependencies (JDE mapping, OTK data) and a high number of Red-flagged tasks indicate a systemic issue in unblocking progress across the portfolio, creating cumulative delays.</a:t>
+              <a:t>Inconsistent milestone reporting (Titan) and a significant gap between 'ahead of schedule' and actual completion (UniSan) indicate foundational planning and tracking issues.</a:t>
             </a:r>
           </a:p>
         </p:txBody>
@@ -5202,7 +5091,7 @@
             <a:avLst/>
           </a:prstGeom>
           <a:solidFill>
-            <a:srgbClr val="FFA500"/>
+            <a:srgbClr val="E53E3E"/>
           </a:solidFill>
           <a:ln>
             <a:noFill/>
@@ -5259,7 +5148,7 @@
                   <a:srgbClr val="FFFFFF"/>
                 </a:solidFill>
               </a:rPr>
-              <a:t>MEDIUM</a:t>
+              <a:t>HIGH</a:t>
             </a:r>
           </a:p>
         </p:txBody>
@@ -5293,7 +5182,7 @@
                   <a:srgbClr val="FFFFFF"/>
                 </a:solidFill>
               </a:rPr>
-              <a:t>Project Management Engagement Bottleneck</a:t>
+              <a:t>Unresolved Critical Dependencies</a:t>
             </a:r>
           </a:p>
         </p:txBody>
@@ -5327,7 +5216,7 @@
                   <a:srgbClr val="8E99AB"/>
                 </a:solidFill>
               </a:rPr>
-              <a:t>Repeated direct requests to the Project Manager for critical meetings on the Titan project suggest a leadership engagement bottleneck, hindering timely decision-making and critical path resolution.</a:t>
+              <a:t>Outstanding JDE mapping and data provisioning continue to block progress on key project phases for Titan, creating downstream impact.</a:t>
             </a:r>
           </a:p>
         </p:txBody>
@@ -5584,7 +5473,7 @@
                   <a:srgbClr val="FFFFFF"/>
                 </a:solidFill>
               </a:rPr>
-              <a:t>**Mandate a Portfolio-Wide Project Plan &amp; Dependency Audit**: Initiate an urgent, independent review of both project plans to ensure logical consistency, realistic scheduling, and clear dependency mapping, specifically addressing the inconsistencies observed in Titan.</a:t>
+              <a:t>Mandate immediate and comprehensive project plan reviews for both Titan and UniSan, focusing on logical dependencies, realistic scheduling, and re-baselining where necessary to ensure plan integrity.</a:t>
             </a:r>
           </a:p>
         </p:txBody>
@@ -5695,7 +5584,7 @@
                   <a:srgbClr val="FFFFFF"/>
                 </a:solidFill>
               </a:rPr>
-              <a:t>**Establish a Dedicated Blocker Resolution Task Force**: Deploy a focused team to immediately address the 42 Red tasks in UniSan and the critical JDE/OTK blockers in Titan, ensuring clear ownership, rapid escalation, and timely resolution to unblock progress.</a:t>
+              <a:t>Require the respective Project Managers to submit detailed recovery plans for all 'Red' and significantly delayed tasks/milestones within 48 hours, with clear ownership and committed dates.</a:t>
             </a:r>
           </a:p>
         </p:txBody>
@@ -5806,7 +5695,7 @@
                   <a:srgbClr val="FFFFFF"/>
                 </a:solidFill>
               </a:rPr>
-              <a:t>**Reinforce Project Leadership Engagement &amp; Accountability**: Ensure Project Managers are proactively addressing critical path items, resolving bottlenecks (e.g., PM meeting requests in Titan), and maintaining transparent, accurate project status reporting aligned with actual work completion.</a:t>
+              <a:t>Address the identified Project Management engagement and leadership gaps, particularly for Titan, ensuring critical path issues are resolved without delay and accountability is clear.</a:t>
             </a:r>
           </a:p>
         </p:txBody>
@@ -5917,7 +5806,7 @@
                   <a:srgbClr val="FFFFFF"/>
                 </a:solidFill>
               </a:rPr>
-              <a:t>**Develop Aggressive Recovery Plans with Contingencies**: Demand and critically review detailed, aggressive recovery plans for both projects within the next 7 days, outlining specific actions, revised timelines, and required resource allocation to mitigate further schedule slippage and re-establish a path to success.</a:t>
+              <a:t>Establish a weekly portfolio review cadence with dedicated focus on resolving cross-project blockers and ensuring consistent reporting of project health metrics.</a:t>
             </a:r>
           </a:p>
         </p:txBody>
@@ -6101,7 +5990,7 @@
                   <a:srgbClr val="FFFFFF"/>
                 </a:solidFill>
               </a:rPr>
-              <a:t>▸  Schedule a direct meeting with both Project Managers (UniSan and Titan) within 24 hours to review their immediate action plans and discuss detailed recovery strategies.</a:t>
+              <a:t>▸  Schedule a direct meeting with the Project Managers for Titan and UniSan within 24 hours to review critical path issues and commitment to recovery plans.</a:t>
             </a:r>
           </a:p>
           <a:p>
@@ -6116,7 +6005,7 @@
                   <a:srgbClr val="FFFFFF"/>
                 </a:solidFill>
               </a:rPr>
-              <a:t>▸  Appoint a senior consultant to oversee the project plan audit and lead the blocker resolution task force, providing bi-weekly progress updates directly to the VP.</a:t>
+              <a:t>▸  Request an urgent deep-dive session with the Titan project team to clarify milestone inconsistencies (e.g., Go Live vs. Migration/Hypercare status) and re-align the schedule.</a:t>
             </a:r>
           </a:p>
           <a:p>
@@ -6131,7 +6020,7 @@
                   <a:srgbClr val="FFFFFF"/>
                 </a:solidFill>
               </a:rPr>
-              <a:t>▸  Request a revised, logically consistent project plan and updated RAG status for Zycus - Titan S2P Implementation by end of next week (July 18th, 2026), demonstrating corrected milestone tracking.</a:t>
+              <a:t>▸  Engage the Delivery Lead to investigate the root causes of UniSan's completion rate deficit and ensure adequate resource allocation to address 'Red' tasks.</a:t>
             </a:r>
           </a:p>
         </p:txBody>

</xml_diff>